<commit_message>
cleaned lesson 2 material
</commit_message>
<xml_diff>
--- a/dev/slides/02-bayesian_engines.pptx
+++ b/dev/slides/02-bayesian_engines.pptx
@@ -5,7 +5,7 @@
     <p:sldMasterId id="2147483648" r:id="rId1"/>
   </p:sldMasterIdLst>
   <p:notesMasterIdLst>
-    <p:notesMasterId r:id="rId27"/>
+    <p:notesMasterId r:id="rId28"/>
   </p:notesMasterIdLst>
   <p:sldIdLst>
     <p:sldId id="256" r:id="rId2"/>
@@ -14,25 +14,26 @@
     <p:sldId id="283" r:id="rId5"/>
     <p:sldId id="257" r:id="rId6"/>
     <p:sldId id="258" r:id="rId7"/>
-    <p:sldId id="259" r:id="rId8"/>
-    <p:sldId id="263" r:id="rId9"/>
-    <p:sldId id="265" r:id="rId10"/>
-    <p:sldId id="266" r:id="rId11"/>
-    <p:sldId id="264" r:id="rId12"/>
-    <p:sldId id="267" r:id="rId13"/>
-    <p:sldId id="268" r:id="rId14"/>
-    <p:sldId id="269" r:id="rId15"/>
-    <p:sldId id="270" r:id="rId16"/>
-    <p:sldId id="271" r:id="rId17"/>
-    <p:sldId id="272" r:id="rId18"/>
-    <p:sldId id="274" r:id="rId19"/>
-    <p:sldId id="275" r:id="rId20"/>
-    <p:sldId id="273" r:id="rId21"/>
-    <p:sldId id="277" r:id="rId22"/>
-    <p:sldId id="276" r:id="rId23"/>
-    <p:sldId id="278" r:id="rId24"/>
-    <p:sldId id="279" r:id="rId25"/>
-    <p:sldId id="280" r:id="rId26"/>
+    <p:sldId id="284" r:id="rId8"/>
+    <p:sldId id="259" r:id="rId9"/>
+    <p:sldId id="263" r:id="rId10"/>
+    <p:sldId id="265" r:id="rId11"/>
+    <p:sldId id="266" r:id="rId12"/>
+    <p:sldId id="264" r:id="rId13"/>
+    <p:sldId id="267" r:id="rId14"/>
+    <p:sldId id="268" r:id="rId15"/>
+    <p:sldId id="269" r:id="rId16"/>
+    <p:sldId id="270" r:id="rId17"/>
+    <p:sldId id="271" r:id="rId18"/>
+    <p:sldId id="272" r:id="rId19"/>
+    <p:sldId id="274" r:id="rId20"/>
+    <p:sldId id="275" r:id="rId21"/>
+    <p:sldId id="273" r:id="rId22"/>
+    <p:sldId id="277" r:id="rId23"/>
+    <p:sldId id="276" r:id="rId24"/>
+    <p:sldId id="278" r:id="rId25"/>
+    <p:sldId id="279" r:id="rId26"/>
+    <p:sldId id="280" r:id="rId27"/>
   </p:sldIdLst>
   <p:sldSz cx="12192000" cy="6858000"/>
   <p:notesSz cx="6858000" cy="9144000"/>
@@ -221,7 +222,7 @@
           <a:p>
             <a:fld id="{82958118-120E-4CD7-976D-063A2C19D374}" type="datetimeFigureOut">
               <a:rPr lang="en-NZ" smtClean="0"/>
-              <a:t>17/04/2026</a:t>
+              <a:t>20/04/2026</a:t>
             </a:fld>
             <a:endParaRPr lang="en-NZ"/>
           </a:p>
@@ -554,7 +555,7 @@
           <a:p>
             <a:fld id="{39CA483F-FF50-407D-AAF8-B9970241732D}" type="slidenum">
               <a:rPr lang="en-NZ" smtClean="0"/>
-              <a:t>18</a:t>
+              <a:t>19</a:t>
             </a:fld>
             <a:endParaRPr lang="en-NZ"/>
           </a:p>
@@ -662,7 +663,7 @@
           <a:p>
             <a:fld id="{39CA483F-FF50-407D-AAF8-B9970241732D}" type="slidenum">
               <a:rPr lang="en-NZ" smtClean="0"/>
-              <a:t>19</a:t>
+              <a:t>20</a:t>
             </a:fld>
             <a:endParaRPr lang="en-NZ"/>
           </a:p>
@@ -770,7 +771,7 @@
           <a:p>
             <a:fld id="{39CA483F-FF50-407D-AAF8-B9970241732D}" type="slidenum">
               <a:rPr lang="en-NZ" smtClean="0"/>
-              <a:t>21</a:t>
+              <a:t>22</a:t>
             </a:fld>
             <a:endParaRPr lang="en-NZ"/>
           </a:p>
@@ -938,7 +939,7 @@
           <a:p>
             <a:fld id="{AE7E5775-8478-43ED-BB22-F704F62C1C87}" type="datetimeFigureOut">
               <a:rPr lang="en-NZ" smtClean="0"/>
-              <a:t>17/04/2026</a:t>
+              <a:t>20/04/2026</a:t>
             </a:fld>
             <a:endParaRPr lang="en-NZ"/>
           </a:p>
@@ -1138,7 +1139,7 @@
           <a:p>
             <a:fld id="{AE7E5775-8478-43ED-BB22-F704F62C1C87}" type="datetimeFigureOut">
               <a:rPr lang="en-NZ" smtClean="0"/>
-              <a:t>17/04/2026</a:t>
+              <a:t>20/04/2026</a:t>
             </a:fld>
             <a:endParaRPr lang="en-NZ"/>
           </a:p>
@@ -1348,7 +1349,7 @@
           <a:p>
             <a:fld id="{AE7E5775-8478-43ED-BB22-F704F62C1C87}" type="datetimeFigureOut">
               <a:rPr lang="en-NZ" smtClean="0"/>
-              <a:t>17/04/2026</a:t>
+              <a:t>20/04/2026</a:t>
             </a:fld>
             <a:endParaRPr lang="en-NZ"/>
           </a:p>
@@ -1548,7 +1549,7 @@
           <a:p>
             <a:fld id="{AE7E5775-8478-43ED-BB22-F704F62C1C87}" type="datetimeFigureOut">
               <a:rPr lang="en-NZ" smtClean="0"/>
-              <a:t>17/04/2026</a:t>
+              <a:t>20/04/2026</a:t>
             </a:fld>
             <a:endParaRPr lang="en-NZ"/>
           </a:p>
@@ -1824,7 +1825,7 @@
           <a:p>
             <a:fld id="{AE7E5775-8478-43ED-BB22-F704F62C1C87}" type="datetimeFigureOut">
               <a:rPr lang="en-NZ" smtClean="0"/>
-              <a:t>17/04/2026</a:t>
+              <a:t>20/04/2026</a:t>
             </a:fld>
             <a:endParaRPr lang="en-NZ"/>
           </a:p>
@@ -2092,7 +2093,7 @@
           <a:p>
             <a:fld id="{AE7E5775-8478-43ED-BB22-F704F62C1C87}" type="datetimeFigureOut">
               <a:rPr lang="en-NZ" smtClean="0"/>
-              <a:t>17/04/2026</a:t>
+              <a:t>20/04/2026</a:t>
             </a:fld>
             <a:endParaRPr lang="en-NZ"/>
           </a:p>
@@ -2507,7 +2508,7 @@
           <a:p>
             <a:fld id="{AE7E5775-8478-43ED-BB22-F704F62C1C87}" type="datetimeFigureOut">
               <a:rPr lang="en-NZ" smtClean="0"/>
-              <a:t>17/04/2026</a:t>
+              <a:t>20/04/2026</a:t>
             </a:fld>
             <a:endParaRPr lang="en-NZ"/>
           </a:p>
@@ -2649,7 +2650,7 @@
           <a:p>
             <a:fld id="{AE7E5775-8478-43ED-BB22-F704F62C1C87}" type="datetimeFigureOut">
               <a:rPr lang="en-NZ" smtClean="0"/>
-              <a:t>17/04/2026</a:t>
+              <a:t>20/04/2026</a:t>
             </a:fld>
             <a:endParaRPr lang="en-NZ"/>
           </a:p>
@@ -2762,7 +2763,7 @@
           <a:p>
             <a:fld id="{AE7E5775-8478-43ED-BB22-F704F62C1C87}" type="datetimeFigureOut">
               <a:rPr lang="en-NZ" smtClean="0"/>
-              <a:t>17/04/2026</a:t>
+              <a:t>20/04/2026</a:t>
             </a:fld>
             <a:endParaRPr lang="en-NZ"/>
           </a:p>
@@ -3075,7 +3076,7 @@
           <a:p>
             <a:fld id="{AE7E5775-8478-43ED-BB22-F704F62C1C87}" type="datetimeFigureOut">
               <a:rPr lang="en-NZ" smtClean="0"/>
-              <a:t>17/04/2026</a:t>
+              <a:t>20/04/2026</a:t>
             </a:fld>
             <a:endParaRPr lang="en-NZ"/>
           </a:p>
@@ -3364,7 +3365,7 @@
           <a:p>
             <a:fld id="{AE7E5775-8478-43ED-BB22-F704F62C1C87}" type="datetimeFigureOut">
               <a:rPr lang="en-NZ" smtClean="0"/>
-              <a:t>17/04/2026</a:t>
+              <a:t>20/04/2026</a:t>
             </a:fld>
             <a:endParaRPr lang="en-NZ"/>
           </a:p>
@@ -3610,7 +3611,7 @@
           <a:p>
             <a:fld id="{AE7E5775-8478-43ED-BB22-F704F62C1C87}" type="datetimeFigureOut">
               <a:rPr lang="en-NZ" smtClean="0"/>
-              <a:t>17/04/2026</a:t>
+              <a:t>20/04/2026</a:t>
             </a:fld>
             <a:endParaRPr lang="en-NZ"/>
           </a:p>
@@ -4085,6 +4086,617 @@
         <p:cNvPr id="1" name="">
           <a:extLst>
             <a:ext uri="{FF2B5EF4-FFF2-40B4-BE49-F238E27FC236}">
+              <a16:creationId xmlns:a16="http://schemas.microsoft.com/office/drawing/2014/main" id="{69360240-EC56-4A99-D4EC-0E420A67FCBD}"/>
+            </a:ext>
+          </a:extLst>
+        </p:cNvPr>
+        <p:cNvGrpSpPr/>
+        <p:nvPr/>
+      </p:nvGrpSpPr>
+      <p:grpSpPr>
+        <a:xfrm>
+          <a:off x="0" y="0"/>
+          <a:ext cx="0" cy="0"/>
+          <a:chOff x="0" y="0"/>
+          <a:chExt cx="0" cy="0"/>
+        </a:xfrm>
+      </p:grpSpPr>
+      <p:sp>
+        <p:nvSpPr>
+          <p:cNvPr id="2" name="Title 1">
+            <a:extLst>
+              <a:ext uri="{FF2B5EF4-FFF2-40B4-BE49-F238E27FC236}">
+                <a16:creationId xmlns:a16="http://schemas.microsoft.com/office/drawing/2014/main" id="{13F93581-CA01-F1BC-A0C5-A9568C12E1BA}"/>
+              </a:ext>
+            </a:extLst>
+          </p:cNvPr>
+          <p:cNvSpPr>
+            <a:spLocks noGrp="1"/>
+          </p:cNvSpPr>
+          <p:nvPr>
+            <p:ph type="title"/>
+          </p:nvPr>
+        </p:nvSpPr>
+        <p:spPr>
+          <a:xfrm>
+            <a:off x="838200" y="1094804"/>
+            <a:ext cx="10515600" cy="595884"/>
+          </a:xfrm>
+        </p:spPr>
+        <p:txBody>
+          <a:bodyPr>
+            <a:normAutofit fontScale="90000"/>
+          </a:bodyPr>
+          <a:lstStyle/>
+          <a:p>
+            <a:r>
+              <a:rPr lang="en-NZ" dirty="0">
+                <a:solidFill>
+                  <a:schemeClr val="bg1"/>
+                </a:solidFill>
+              </a:rPr>
+              <a:t>The long inefficient way: counting</a:t>
+            </a:r>
+          </a:p>
+        </p:txBody>
+      </p:sp>
+      <p:grpSp>
+        <p:nvGrpSpPr>
+          <p:cNvPr id="4" name="Group 3">
+            <a:extLst>
+              <a:ext uri="{FF2B5EF4-FFF2-40B4-BE49-F238E27FC236}">
+                <a16:creationId xmlns:a16="http://schemas.microsoft.com/office/drawing/2014/main" id="{194492E4-229A-7EC6-A2FA-947D11122DB9}"/>
+              </a:ext>
+            </a:extLst>
+          </p:cNvPr>
+          <p:cNvGrpSpPr/>
+          <p:nvPr/>
+        </p:nvGrpSpPr>
+        <p:grpSpPr>
+          <a:xfrm rot="5400000" flipH="1">
+            <a:off x="1040508" y="3031997"/>
+            <a:ext cx="595884" cy="618174"/>
+            <a:chOff x="475488" y="1595628"/>
+            <a:chExt cx="3666744" cy="3803904"/>
+          </a:xfrm>
+        </p:grpSpPr>
+        <p:sp>
+          <p:nvSpPr>
+            <p:cNvPr id="5" name="Oval 4">
+              <a:extLst>
+                <a:ext uri="{FF2B5EF4-FFF2-40B4-BE49-F238E27FC236}">
+                  <a16:creationId xmlns:a16="http://schemas.microsoft.com/office/drawing/2014/main" id="{688B6365-ED0F-5D98-D55F-DD89B6AD959E}"/>
+                </a:ext>
+              </a:extLst>
+            </p:cNvPr>
+            <p:cNvSpPr/>
+            <p:nvPr/>
+          </p:nvSpPr>
+          <p:spPr>
+            <a:xfrm>
+              <a:off x="475488" y="1595628"/>
+              <a:ext cx="3666744" cy="3666744"/>
+            </a:xfrm>
+            <a:prstGeom prst="ellipse">
+              <a:avLst/>
+            </a:prstGeom>
+            <a:solidFill>
+              <a:schemeClr val="tx1">
+                <a:lumMod val="85000"/>
+                <a:lumOff val="15000"/>
+              </a:schemeClr>
+            </a:solidFill>
+            <a:ln>
+              <a:noFill/>
+            </a:ln>
+          </p:spPr>
+          <p:style>
+            <a:lnRef idx="2">
+              <a:schemeClr val="accent1">
+                <a:shade val="15000"/>
+              </a:schemeClr>
+            </a:lnRef>
+            <a:fillRef idx="1">
+              <a:schemeClr val="accent1"/>
+            </a:fillRef>
+            <a:effectRef idx="0">
+              <a:schemeClr val="accent1"/>
+            </a:effectRef>
+            <a:fontRef idx="minor">
+              <a:schemeClr val="lt1"/>
+            </a:fontRef>
+          </p:style>
+          <p:txBody>
+            <a:bodyPr rtlCol="0" anchor="ctr"/>
+            <a:lstStyle/>
+            <a:p>
+              <a:pPr algn="ctr"/>
+              <a:endParaRPr lang="en-NZ"/>
+            </a:p>
+          </p:txBody>
+        </p:sp>
+        <p:sp>
+          <p:nvSpPr>
+            <p:cNvPr id="6" name="Partial Circle 5">
+              <a:extLst>
+                <a:ext uri="{FF2B5EF4-FFF2-40B4-BE49-F238E27FC236}">
+                  <a16:creationId xmlns:a16="http://schemas.microsoft.com/office/drawing/2014/main" id="{B936B2F3-761E-2FAC-6FF3-542F40CADEAE}"/>
+                </a:ext>
+              </a:extLst>
+            </p:cNvPr>
+            <p:cNvSpPr/>
+            <p:nvPr/>
+          </p:nvSpPr>
+          <p:spPr>
+            <a:xfrm rot="16200000">
+              <a:off x="406908" y="1664208"/>
+              <a:ext cx="3803904" cy="3666744"/>
+            </a:xfrm>
+            <a:prstGeom prst="pie">
+              <a:avLst>
+                <a:gd name="adj1" fmla="val 28755"/>
+                <a:gd name="adj2" fmla="val 5418458"/>
+              </a:avLst>
+            </a:prstGeom>
+            <a:solidFill>
+              <a:schemeClr val="accent2">
+                <a:lumMod val="60000"/>
+                <a:lumOff val="40000"/>
+              </a:schemeClr>
+            </a:solidFill>
+            <a:ln>
+              <a:noFill/>
+            </a:ln>
+          </p:spPr>
+          <p:style>
+            <a:lnRef idx="2">
+              <a:schemeClr val="accent1">
+                <a:shade val="15000"/>
+              </a:schemeClr>
+            </a:lnRef>
+            <a:fillRef idx="1">
+              <a:schemeClr val="accent1"/>
+            </a:fillRef>
+            <a:effectRef idx="0">
+              <a:schemeClr val="accent1"/>
+            </a:effectRef>
+            <a:fontRef idx="minor">
+              <a:schemeClr val="lt1"/>
+            </a:fontRef>
+          </p:style>
+          <p:txBody>
+            <a:bodyPr rtlCol="0" anchor="ctr"/>
+            <a:lstStyle/>
+            <a:p>
+              <a:pPr algn="ctr"/>
+              <a:endParaRPr lang="en-NZ">
+                <a:solidFill>
+                  <a:schemeClr val="tx1"/>
+                </a:solidFill>
+              </a:endParaRPr>
+            </a:p>
+          </p:txBody>
+        </p:sp>
+      </p:grpSp>
+      <p:grpSp>
+        <p:nvGrpSpPr>
+          <p:cNvPr id="7" name="Group 6">
+            <a:extLst>
+              <a:ext uri="{FF2B5EF4-FFF2-40B4-BE49-F238E27FC236}">
+                <a16:creationId xmlns:a16="http://schemas.microsoft.com/office/drawing/2014/main" id="{58F18D39-0B51-4F30-D3FC-E7184993C181}"/>
+              </a:ext>
+            </a:extLst>
+          </p:cNvPr>
+          <p:cNvGrpSpPr/>
+          <p:nvPr/>
+        </p:nvGrpSpPr>
+        <p:grpSpPr>
+          <a:xfrm rot="10800000" flipH="1">
+            <a:off x="1062797" y="3837813"/>
+            <a:ext cx="595884" cy="595884"/>
+            <a:chOff x="4916424" y="1690688"/>
+            <a:chExt cx="3666744" cy="3666744"/>
+          </a:xfrm>
+        </p:grpSpPr>
+        <p:sp>
+          <p:nvSpPr>
+            <p:cNvPr id="8" name="Oval 7">
+              <a:extLst>
+                <a:ext uri="{FF2B5EF4-FFF2-40B4-BE49-F238E27FC236}">
+                  <a16:creationId xmlns:a16="http://schemas.microsoft.com/office/drawing/2014/main" id="{CE4DDD9D-3551-23CC-8168-E41EC9CE6603}"/>
+                </a:ext>
+              </a:extLst>
+            </p:cNvPr>
+            <p:cNvSpPr/>
+            <p:nvPr/>
+          </p:nvSpPr>
+          <p:spPr>
+            <a:xfrm>
+              <a:off x="4916424" y="1690688"/>
+              <a:ext cx="3666744" cy="3666744"/>
+            </a:xfrm>
+            <a:prstGeom prst="ellipse">
+              <a:avLst/>
+            </a:prstGeom>
+            <a:solidFill>
+              <a:schemeClr val="tx1">
+                <a:lumMod val="85000"/>
+                <a:lumOff val="15000"/>
+              </a:schemeClr>
+            </a:solidFill>
+            <a:ln>
+              <a:noFill/>
+            </a:ln>
+          </p:spPr>
+          <p:style>
+            <a:lnRef idx="2">
+              <a:schemeClr val="accent1">
+                <a:shade val="15000"/>
+              </a:schemeClr>
+            </a:lnRef>
+            <a:fillRef idx="1">
+              <a:schemeClr val="accent1"/>
+            </a:fillRef>
+            <a:effectRef idx="0">
+              <a:schemeClr val="accent1"/>
+            </a:effectRef>
+            <a:fontRef idx="minor">
+              <a:schemeClr val="lt1"/>
+            </a:fontRef>
+          </p:style>
+          <p:txBody>
+            <a:bodyPr rtlCol="0" anchor="ctr"/>
+            <a:lstStyle/>
+            <a:p>
+              <a:pPr algn="ctr"/>
+              <a:endParaRPr lang="en-NZ"/>
+            </a:p>
+          </p:txBody>
+        </p:sp>
+        <p:sp>
+          <p:nvSpPr>
+            <p:cNvPr id="9" name="Partial Circle 8">
+              <a:extLst>
+                <a:ext uri="{FF2B5EF4-FFF2-40B4-BE49-F238E27FC236}">
+                  <a16:creationId xmlns:a16="http://schemas.microsoft.com/office/drawing/2014/main" id="{C6B1DD03-53D0-FAF4-BBA4-3827A1A35D8C}"/>
+                </a:ext>
+              </a:extLst>
+            </p:cNvPr>
+            <p:cNvSpPr/>
+            <p:nvPr/>
+          </p:nvSpPr>
+          <p:spPr>
+            <a:xfrm rot="16200000">
+              <a:off x="4916424" y="1690688"/>
+              <a:ext cx="3666744" cy="3666744"/>
+            </a:xfrm>
+            <a:prstGeom prst="pie">
+              <a:avLst>
+                <a:gd name="adj1" fmla="val 28755"/>
+                <a:gd name="adj2" fmla="val 10825612"/>
+              </a:avLst>
+            </a:prstGeom>
+            <a:solidFill>
+              <a:schemeClr val="accent2">
+                <a:lumMod val="60000"/>
+                <a:lumOff val="40000"/>
+              </a:schemeClr>
+            </a:solidFill>
+            <a:ln>
+              <a:noFill/>
+            </a:ln>
+          </p:spPr>
+          <p:style>
+            <a:lnRef idx="2">
+              <a:schemeClr val="accent1">
+                <a:shade val="15000"/>
+              </a:schemeClr>
+            </a:lnRef>
+            <a:fillRef idx="1">
+              <a:schemeClr val="accent1"/>
+            </a:fillRef>
+            <a:effectRef idx="0">
+              <a:schemeClr val="accent1"/>
+            </a:effectRef>
+            <a:fontRef idx="minor">
+              <a:schemeClr val="lt1"/>
+            </a:fontRef>
+          </p:style>
+          <p:txBody>
+            <a:bodyPr rtlCol="0" anchor="ctr"/>
+            <a:lstStyle/>
+            <a:p>
+              <a:pPr algn="ctr"/>
+              <a:endParaRPr lang="en-NZ">
+                <a:solidFill>
+                  <a:schemeClr val="tx1"/>
+                </a:solidFill>
+              </a:endParaRPr>
+            </a:p>
+          </p:txBody>
+        </p:sp>
+      </p:grpSp>
+      <p:grpSp>
+        <p:nvGrpSpPr>
+          <p:cNvPr id="10" name="Group 9">
+            <a:extLst>
+              <a:ext uri="{FF2B5EF4-FFF2-40B4-BE49-F238E27FC236}">
+                <a16:creationId xmlns:a16="http://schemas.microsoft.com/office/drawing/2014/main" id="{7ABC2C2B-B40F-BF0A-E720-A4340FCD540B}"/>
+              </a:ext>
+            </a:extLst>
+          </p:cNvPr>
+          <p:cNvGrpSpPr/>
+          <p:nvPr/>
+        </p:nvGrpSpPr>
+        <p:grpSpPr>
+          <a:xfrm rot="16200000" flipH="1">
+            <a:off x="1029362" y="4632484"/>
+            <a:ext cx="595884" cy="595884"/>
+            <a:chOff x="8145780" y="1528572"/>
+            <a:chExt cx="3666744" cy="3666744"/>
+          </a:xfrm>
+        </p:grpSpPr>
+        <p:sp>
+          <p:nvSpPr>
+            <p:cNvPr id="11" name="Oval 10">
+              <a:extLst>
+                <a:ext uri="{FF2B5EF4-FFF2-40B4-BE49-F238E27FC236}">
+                  <a16:creationId xmlns:a16="http://schemas.microsoft.com/office/drawing/2014/main" id="{C99B8009-D50C-F86A-1449-F367D1831411}"/>
+                </a:ext>
+              </a:extLst>
+            </p:cNvPr>
+            <p:cNvSpPr/>
+            <p:nvPr/>
+          </p:nvSpPr>
+          <p:spPr>
+            <a:xfrm>
+              <a:off x="8145780" y="1528572"/>
+              <a:ext cx="3666744" cy="3666744"/>
+            </a:xfrm>
+            <a:prstGeom prst="ellipse">
+              <a:avLst/>
+            </a:prstGeom>
+            <a:solidFill>
+              <a:schemeClr val="tx1">
+                <a:lumMod val="85000"/>
+                <a:lumOff val="15000"/>
+              </a:schemeClr>
+            </a:solidFill>
+            <a:ln>
+              <a:noFill/>
+            </a:ln>
+          </p:spPr>
+          <p:style>
+            <a:lnRef idx="2">
+              <a:schemeClr val="accent1">
+                <a:shade val="15000"/>
+              </a:schemeClr>
+            </a:lnRef>
+            <a:fillRef idx="1">
+              <a:schemeClr val="accent1"/>
+            </a:fillRef>
+            <a:effectRef idx="0">
+              <a:schemeClr val="accent1"/>
+            </a:effectRef>
+            <a:fontRef idx="minor">
+              <a:schemeClr val="lt1"/>
+            </a:fontRef>
+          </p:style>
+          <p:txBody>
+            <a:bodyPr rtlCol="0" anchor="ctr"/>
+            <a:lstStyle/>
+            <a:p>
+              <a:pPr algn="ctr"/>
+              <a:endParaRPr lang="en-NZ"/>
+            </a:p>
+          </p:txBody>
+        </p:sp>
+        <p:sp>
+          <p:nvSpPr>
+            <p:cNvPr id="12" name="Partial Circle 11">
+              <a:extLst>
+                <a:ext uri="{FF2B5EF4-FFF2-40B4-BE49-F238E27FC236}">
+                  <a16:creationId xmlns:a16="http://schemas.microsoft.com/office/drawing/2014/main" id="{11EBD056-EC85-05CE-4EF5-04CD3215B77C}"/>
+                </a:ext>
+              </a:extLst>
+            </p:cNvPr>
+            <p:cNvSpPr/>
+            <p:nvPr/>
+          </p:nvSpPr>
+          <p:spPr>
+            <a:xfrm rot="16200000">
+              <a:off x="8145780" y="1528572"/>
+              <a:ext cx="3666744" cy="3666744"/>
+            </a:xfrm>
+            <a:prstGeom prst="pie">
+              <a:avLst>
+                <a:gd name="adj1" fmla="val 28755"/>
+                <a:gd name="adj2" fmla="val 16212288"/>
+              </a:avLst>
+            </a:prstGeom>
+            <a:solidFill>
+              <a:schemeClr val="accent2">
+                <a:lumMod val="60000"/>
+                <a:lumOff val="40000"/>
+              </a:schemeClr>
+            </a:solidFill>
+            <a:ln>
+              <a:noFill/>
+            </a:ln>
+          </p:spPr>
+          <p:style>
+            <a:lnRef idx="2">
+              <a:schemeClr val="accent1">
+                <a:shade val="15000"/>
+              </a:schemeClr>
+            </a:lnRef>
+            <a:fillRef idx="1">
+              <a:schemeClr val="accent1"/>
+            </a:fillRef>
+            <a:effectRef idx="0">
+              <a:schemeClr val="accent1"/>
+            </a:effectRef>
+            <a:fontRef idx="minor">
+              <a:schemeClr val="lt1"/>
+            </a:fontRef>
+          </p:style>
+          <p:txBody>
+            <a:bodyPr rtlCol="0" anchor="ctr"/>
+            <a:lstStyle/>
+            <a:p>
+              <a:pPr algn="ctr"/>
+              <a:endParaRPr lang="en-NZ">
+                <a:solidFill>
+                  <a:schemeClr val="tx1"/>
+                </a:solidFill>
+              </a:endParaRPr>
+            </a:p>
+          </p:txBody>
+        </p:sp>
+      </p:grpSp>
+      <p:sp>
+        <p:nvSpPr>
+          <p:cNvPr id="13" name="Oval 12">
+            <a:extLst>
+              <a:ext uri="{FF2B5EF4-FFF2-40B4-BE49-F238E27FC236}">
+                <a16:creationId xmlns:a16="http://schemas.microsoft.com/office/drawing/2014/main" id="{C84B0BAB-927C-5589-F10D-811EC9442761}"/>
+              </a:ext>
+            </a:extLst>
+          </p:cNvPr>
+          <p:cNvSpPr/>
+          <p:nvPr/>
+        </p:nvSpPr>
+        <p:spPr>
+          <a:xfrm flipH="1">
+            <a:off x="1040507" y="5427154"/>
+            <a:ext cx="595884" cy="595884"/>
+          </a:xfrm>
+          <a:prstGeom prst="ellipse">
+            <a:avLst/>
+          </a:prstGeom>
+          <a:solidFill>
+            <a:schemeClr val="accent2">
+              <a:lumMod val="60000"/>
+              <a:lumOff val="40000"/>
+            </a:schemeClr>
+          </a:solidFill>
+          <a:ln>
+            <a:noFill/>
+          </a:ln>
+        </p:spPr>
+        <p:style>
+          <a:lnRef idx="2">
+            <a:schemeClr val="accent1">
+              <a:shade val="15000"/>
+            </a:schemeClr>
+          </a:lnRef>
+          <a:fillRef idx="1">
+            <a:schemeClr val="accent1"/>
+          </a:fillRef>
+          <a:effectRef idx="0">
+            <a:schemeClr val="accent1"/>
+          </a:effectRef>
+          <a:fontRef idx="minor">
+            <a:schemeClr val="lt1"/>
+          </a:fontRef>
+        </p:style>
+        <p:txBody>
+          <a:bodyPr rtlCol="0" anchor="ctr"/>
+          <a:lstStyle/>
+          <a:p>
+            <a:pPr algn="ctr"/>
+            <a:endParaRPr lang="en-NZ"/>
+          </a:p>
+        </p:txBody>
+      </p:sp>
+      <p:sp>
+        <p:nvSpPr>
+          <p:cNvPr id="14" name="Oval 13">
+            <a:extLst>
+              <a:ext uri="{FF2B5EF4-FFF2-40B4-BE49-F238E27FC236}">
+                <a16:creationId xmlns:a16="http://schemas.microsoft.com/office/drawing/2014/main" id="{D2CDF11C-4E3F-1F5C-1CEC-87539EFA8724}"/>
+              </a:ext>
+            </a:extLst>
+          </p:cNvPr>
+          <p:cNvSpPr/>
+          <p:nvPr/>
+        </p:nvSpPr>
+        <p:spPr>
+          <a:xfrm flipH="1">
+            <a:off x="1051653" y="2248472"/>
+            <a:ext cx="595884" cy="595884"/>
+          </a:xfrm>
+          <a:prstGeom prst="ellipse">
+            <a:avLst/>
+          </a:prstGeom>
+          <a:solidFill>
+            <a:schemeClr val="tx1">
+              <a:lumMod val="85000"/>
+              <a:lumOff val="15000"/>
+            </a:schemeClr>
+          </a:solidFill>
+          <a:ln>
+            <a:noFill/>
+          </a:ln>
+        </p:spPr>
+        <p:style>
+          <a:lnRef idx="2">
+            <a:schemeClr val="accent1">
+              <a:shade val="15000"/>
+            </a:schemeClr>
+          </a:lnRef>
+          <a:fillRef idx="1">
+            <a:schemeClr val="accent1"/>
+          </a:fillRef>
+          <a:effectRef idx="0">
+            <a:schemeClr val="accent1"/>
+          </a:effectRef>
+          <a:fontRef idx="minor">
+            <a:schemeClr val="lt1"/>
+          </a:fontRef>
+        </p:style>
+        <p:txBody>
+          <a:bodyPr rtlCol="0" anchor="ctr"/>
+          <a:lstStyle/>
+          <a:p>
+            <a:pPr algn="ctr"/>
+            <a:endParaRPr lang="en-NZ"/>
+          </a:p>
+        </p:txBody>
+      </p:sp>
+    </p:spTree>
+    <p:extLst>
+      <p:ext uri="{BB962C8B-B14F-4D97-AF65-F5344CB8AC3E}">
+        <p14:creationId xmlns:p14="http://schemas.microsoft.com/office/powerpoint/2010/main" val="3302430848"/>
+      </p:ext>
+    </p:extLst>
+  </p:cSld>
+  <p:clrMapOvr>
+    <a:masterClrMapping/>
+  </p:clrMapOvr>
+  <mc:AlternateContent xmlns:mc="http://schemas.openxmlformats.org/markup-compatibility/2006" xmlns:p159="http://schemas.microsoft.com/office/powerpoint/2015/09/main">
+    <mc:Choice Requires="p159">
+      <p:transition xmlns:p14="http://schemas.microsoft.com/office/powerpoint/2010/main" spd="slow" p14:dur="2000">
+        <p159:morph option="byObject"/>
+      </p:transition>
+    </mc:Choice>
+    <mc:Fallback xmlns="">
+      <p:transition spd="slow">
+        <p:fade/>
+      </p:transition>
+    </mc:Fallback>
+  </mc:AlternateContent>
+</p:sld>
+</file>
+
+<file path=ppt/slides/slide11.xml><?xml version="1.0" encoding="utf-8"?>
+<p:sld xmlns:a="http://schemas.openxmlformats.org/drawingml/2006/main" xmlns:r="http://schemas.openxmlformats.org/officeDocument/2006/relationships" xmlns:p="http://schemas.openxmlformats.org/presentationml/2006/main">
+  <p:cSld>
+    <p:spTree>
+      <p:nvGrpSpPr>
+        <p:cNvPr id="1" name="">
+          <a:extLst>
+            <a:ext uri="{FF2B5EF4-FFF2-40B4-BE49-F238E27FC236}">
               <a16:creationId xmlns:a16="http://schemas.microsoft.com/office/drawing/2014/main" id="{D99C385E-45FE-F11F-E216-2EB694A0D7D8}"/>
             </a:ext>
           </a:extLst>
@@ -5501,7 +6113,7 @@
 </p:sld>
 </file>
 
-<file path=ppt/slides/slide11.xml><?xml version="1.0" encoding="utf-8"?>
+<file path=ppt/slides/slide12.xml><?xml version="1.0" encoding="utf-8"?>
 <p:sld xmlns:a="http://schemas.openxmlformats.org/drawingml/2006/main" xmlns:r="http://schemas.openxmlformats.org/officeDocument/2006/relationships" xmlns:p="http://schemas.openxmlformats.org/presentationml/2006/main">
   <p:cSld>
     <p:spTree>
@@ -7711,7 +8323,7 @@
 </p:sld>
 </file>
 
-<file path=ppt/slides/slide12.xml><?xml version="1.0" encoding="utf-8"?>
+<file path=ppt/slides/slide13.xml><?xml version="1.0" encoding="utf-8"?>
 <p:sld xmlns:a="http://schemas.openxmlformats.org/drawingml/2006/main" xmlns:r="http://schemas.openxmlformats.org/officeDocument/2006/relationships" xmlns:p="http://schemas.openxmlformats.org/presentationml/2006/main">
   <p:cSld>
     <p:spTree>
@@ -10288,7 +10900,7 @@
 </p:sld>
 </file>
 
-<file path=ppt/slides/slide13.xml><?xml version="1.0" encoding="utf-8"?>
+<file path=ppt/slides/slide14.xml><?xml version="1.0" encoding="utf-8"?>
 <p:sld xmlns:a="http://schemas.openxmlformats.org/drawingml/2006/main" xmlns:r="http://schemas.openxmlformats.org/officeDocument/2006/relationships" xmlns:p="http://schemas.openxmlformats.org/presentationml/2006/main">
   <p:cSld>
     <p:spTree>
@@ -13081,7 +13693,7 @@
 </p:sld>
 </file>
 
-<file path=ppt/slides/slide14.xml><?xml version="1.0" encoding="utf-8"?>
+<file path=ppt/slides/slide15.xml><?xml version="1.0" encoding="utf-8"?>
 <p:sld xmlns:a="http://schemas.openxmlformats.org/drawingml/2006/main" xmlns:r="http://schemas.openxmlformats.org/officeDocument/2006/relationships" xmlns:p="http://schemas.openxmlformats.org/presentationml/2006/main">
   <p:cSld>
     <p:spTree>
@@ -16090,7 +16702,7 @@
 </p:sld>
 </file>
 
-<file path=ppt/slides/slide15.xml><?xml version="1.0" encoding="utf-8"?>
+<file path=ppt/slides/slide16.xml><?xml version="1.0" encoding="utf-8"?>
 <p:sld xmlns:a="http://schemas.openxmlformats.org/drawingml/2006/main" xmlns:r="http://schemas.openxmlformats.org/officeDocument/2006/relationships" xmlns:p="http://schemas.openxmlformats.org/presentationml/2006/main">
   <p:cSld>
     <p:spTree>
@@ -19531,7 +20143,7 @@
 </p:sld>
 </file>
 
-<file path=ppt/slides/slide16.xml><?xml version="1.0" encoding="utf-8"?>
+<file path=ppt/slides/slide17.xml><?xml version="1.0" encoding="utf-8"?>
 <p:sld xmlns:a="http://schemas.openxmlformats.org/drawingml/2006/main" xmlns:r="http://schemas.openxmlformats.org/officeDocument/2006/relationships" xmlns:p="http://schemas.openxmlformats.org/presentationml/2006/main">
   <p:cSld>
     <p:spTree>
@@ -24144,7 +24756,7 @@
 </p:sld>
 </file>
 
-<file path=ppt/slides/slide17.xml><?xml version="1.0" encoding="utf-8"?>
+<file path=ppt/slides/slide18.xml><?xml version="1.0" encoding="utf-8"?>
 <p:sld xmlns:a="http://schemas.openxmlformats.org/drawingml/2006/main" xmlns:r="http://schemas.openxmlformats.org/officeDocument/2006/relationships" xmlns:p="http://schemas.openxmlformats.org/presentationml/2006/main">
   <p:cSld>
     <p:spTree>
@@ -26876,7 +27488,7 @@
 </p:sld>
 </file>
 
-<file path=ppt/slides/slide18.xml><?xml version="1.0" encoding="utf-8"?>
+<file path=ppt/slides/slide19.xml><?xml version="1.0" encoding="utf-8"?>
 <p:sld xmlns:a="http://schemas.openxmlformats.org/drawingml/2006/main" xmlns:r="http://schemas.openxmlformats.org/officeDocument/2006/relationships" xmlns:p="http://schemas.openxmlformats.org/presentationml/2006/main">
   <p:cSld>
     <p:spTree>
@@ -28596,7 +29208,126 @@
 </p:sld>
 </file>
 
-<file path=ppt/slides/slide19.xml><?xml version="1.0" encoding="utf-8"?>
+<file path=ppt/slides/slide2.xml><?xml version="1.0" encoding="utf-8"?>
+<p:sld xmlns:a="http://schemas.openxmlformats.org/drawingml/2006/main" xmlns:r="http://schemas.openxmlformats.org/officeDocument/2006/relationships" xmlns:p="http://schemas.openxmlformats.org/presentationml/2006/main">
+  <p:cSld>
+    <p:spTree>
+      <p:nvGrpSpPr>
+        <p:cNvPr id="1" name=""/>
+        <p:cNvGrpSpPr/>
+        <p:nvPr/>
+      </p:nvGrpSpPr>
+      <p:grpSpPr>
+        <a:xfrm>
+          <a:off x="0" y="0"/>
+          <a:ext cx="0" cy="0"/>
+          <a:chOff x="0" y="0"/>
+          <a:chExt cx="0" cy="0"/>
+        </a:xfrm>
+      </p:grpSpPr>
+      <p:sp>
+        <p:nvSpPr>
+          <p:cNvPr id="2" name="Title 1">
+            <a:extLst>
+              <a:ext uri="{FF2B5EF4-FFF2-40B4-BE49-F238E27FC236}">
+                <a16:creationId xmlns:a16="http://schemas.microsoft.com/office/drawing/2014/main" id="{F03E1DC7-3521-765A-831B-520C5FBB81E0}"/>
+              </a:ext>
+            </a:extLst>
+          </p:cNvPr>
+          <p:cNvSpPr>
+            <a:spLocks noGrp="1"/>
+          </p:cNvSpPr>
+          <p:nvPr>
+            <p:ph type="title"/>
+          </p:nvPr>
+        </p:nvSpPr>
+        <p:spPr/>
+        <p:txBody>
+          <a:bodyPr/>
+          <a:lstStyle/>
+          <a:p>
+            <a:r>
+              <a:rPr lang="en-NZ" dirty="0">
+                <a:solidFill>
+                  <a:schemeClr val="bg1"/>
+                </a:solidFill>
+              </a:rPr>
+              <a:t>Coming up…</a:t>
+            </a:r>
+          </a:p>
+        </p:txBody>
+      </p:sp>
+      <p:sp>
+        <p:nvSpPr>
+          <p:cNvPr id="3" name="Content Placeholder 2">
+            <a:extLst>
+              <a:ext uri="{FF2B5EF4-FFF2-40B4-BE49-F238E27FC236}">
+                <a16:creationId xmlns:a16="http://schemas.microsoft.com/office/drawing/2014/main" id="{EB8F7E9B-CCA2-0978-93D7-D0F8167BD926}"/>
+              </a:ext>
+            </a:extLst>
+          </p:cNvPr>
+          <p:cNvSpPr>
+            <a:spLocks noGrp="1"/>
+          </p:cNvSpPr>
+          <p:nvPr>
+            <p:ph idx="1"/>
+          </p:nvPr>
+        </p:nvSpPr>
+        <p:spPr>
+          <a:xfrm>
+            <a:off x="838200" y="1825625"/>
+            <a:ext cx="10515600" cy="1777111"/>
+          </a:xfrm>
+        </p:spPr>
+        <p:txBody>
+          <a:bodyPr/>
+          <a:lstStyle/>
+          <a:p>
+            <a:r>
+              <a:rPr lang="en-NZ" dirty="0">
+                <a:solidFill>
+                  <a:schemeClr val="bg1"/>
+                </a:solidFill>
+              </a:rPr>
+              <a:t>Estimating the prevalence of Aphantasia </a:t>
+            </a:r>
+          </a:p>
+          <a:p>
+            <a:r>
+              <a:rPr lang="en-NZ" dirty="0">
+                <a:solidFill>
+                  <a:schemeClr val="bg1"/>
+                </a:solidFill>
+              </a:rPr>
+              <a:t>Manually computing probabilities</a:t>
+            </a:r>
+          </a:p>
+          <a:p>
+            <a:r>
+              <a:rPr lang="en-NZ" dirty="0">
+                <a:solidFill>
+                  <a:schemeClr val="bg1"/>
+                </a:solidFill>
+              </a:rPr>
+              <a:t>Writing a simple Bayesian model</a:t>
+            </a:r>
+          </a:p>
+        </p:txBody>
+      </p:sp>
+    </p:spTree>
+    <p:extLst>
+      <p:ext uri="{BB962C8B-B14F-4D97-AF65-F5344CB8AC3E}">
+        <p14:creationId xmlns:p14="http://schemas.microsoft.com/office/powerpoint/2010/main" val="3806188572"/>
+      </p:ext>
+    </p:extLst>
+  </p:cSld>
+  <p:clrMapOvr>
+    <a:masterClrMapping/>
+  </p:clrMapOvr>
+</p:sld>
+</file>
+
+<file path=ppt/slides/slide20.xml><?xml version="1.0" encoding="utf-8"?>
 <p:sld xmlns:a="http://schemas.openxmlformats.org/drawingml/2006/main" xmlns:r="http://schemas.openxmlformats.org/officeDocument/2006/relationships" xmlns:p="http://schemas.openxmlformats.org/presentationml/2006/main">
   <p:cSld>
     <p:spTree>
@@ -31100,126 +31831,7 @@
 </p:sld>
 </file>
 
-<file path=ppt/slides/slide2.xml><?xml version="1.0" encoding="utf-8"?>
-<p:sld xmlns:a="http://schemas.openxmlformats.org/drawingml/2006/main" xmlns:r="http://schemas.openxmlformats.org/officeDocument/2006/relationships" xmlns:p="http://schemas.openxmlformats.org/presentationml/2006/main">
-  <p:cSld>
-    <p:spTree>
-      <p:nvGrpSpPr>
-        <p:cNvPr id="1" name=""/>
-        <p:cNvGrpSpPr/>
-        <p:nvPr/>
-      </p:nvGrpSpPr>
-      <p:grpSpPr>
-        <a:xfrm>
-          <a:off x="0" y="0"/>
-          <a:ext cx="0" cy="0"/>
-          <a:chOff x="0" y="0"/>
-          <a:chExt cx="0" cy="0"/>
-        </a:xfrm>
-      </p:grpSpPr>
-      <p:sp>
-        <p:nvSpPr>
-          <p:cNvPr id="2" name="Title 1">
-            <a:extLst>
-              <a:ext uri="{FF2B5EF4-FFF2-40B4-BE49-F238E27FC236}">
-                <a16:creationId xmlns:a16="http://schemas.microsoft.com/office/drawing/2014/main" id="{F03E1DC7-3521-765A-831B-520C5FBB81E0}"/>
-              </a:ext>
-            </a:extLst>
-          </p:cNvPr>
-          <p:cNvSpPr>
-            <a:spLocks noGrp="1"/>
-          </p:cNvSpPr>
-          <p:nvPr>
-            <p:ph type="title"/>
-          </p:nvPr>
-        </p:nvSpPr>
-        <p:spPr/>
-        <p:txBody>
-          <a:bodyPr/>
-          <a:lstStyle/>
-          <a:p>
-            <a:r>
-              <a:rPr lang="en-NZ" dirty="0">
-                <a:solidFill>
-                  <a:schemeClr val="bg1"/>
-                </a:solidFill>
-              </a:rPr>
-              <a:t>Coming up…</a:t>
-            </a:r>
-          </a:p>
-        </p:txBody>
-      </p:sp>
-      <p:sp>
-        <p:nvSpPr>
-          <p:cNvPr id="3" name="Content Placeholder 2">
-            <a:extLst>
-              <a:ext uri="{FF2B5EF4-FFF2-40B4-BE49-F238E27FC236}">
-                <a16:creationId xmlns:a16="http://schemas.microsoft.com/office/drawing/2014/main" id="{EB8F7E9B-CCA2-0978-93D7-D0F8167BD926}"/>
-              </a:ext>
-            </a:extLst>
-          </p:cNvPr>
-          <p:cNvSpPr>
-            <a:spLocks noGrp="1"/>
-          </p:cNvSpPr>
-          <p:nvPr>
-            <p:ph idx="1"/>
-          </p:nvPr>
-        </p:nvSpPr>
-        <p:spPr>
-          <a:xfrm>
-            <a:off x="838200" y="1825625"/>
-            <a:ext cx="10515600" cy="1777111"/>
-          </a:xfrm>
-        </p:spPr>
-        <p:txBody>
-          <a:bodyPr/>
-          <a:lstStyle/>
-          <a:p>
-            <a:r>
-              <a:rPr lang="en-NZ" dirty="0">
-                <a:solidFill>
-                  <a:schemeClr val="bg1"/>
-                </a:solidFill>
-              </a:rPr>
-              <a:t>Estimating the prevalence of Aphantasia </a:t>
-            </a:r>
-          </a:p>
-          <a:p>
-            <a:r>
-              <a:rPr lang="en-NZ" dirty="0">
-                <a:solidFill>
-                  <a:schemeClr val="bg1"/>
-                </a:solidFill>
-              </a:rPr>
-              <a:t>Manually computing probabilities</a:t>
-            </a:r>
-          </a:p>
-          <a:p>
-            <a:r>
-              <a:rPr lang="en-NZ" dirty="0">
-                <a:solidFill>
-                  <a:schemeClr val="bg1"/>
-                </a:solidFill>
-              </a:rPr>
-              <a:t>Writing a simple Bayesian model</a:t>
-            </a:r>
-          </a:p>
-        </p:txBody>
-      </p:sp>
-    </p:spTree>
-    <p:extLst>
-      <p:ext uri="{BB962C8B-B14F-4D97-AF65-F5344CB8AC3E}">
-        <p14:creationId xmlns:p14="http://schemas.microsoft.com/office/powerpoint/2010/main" val="3806188572"/>
-      </p:ext>
-    </p:extLst>
-  </p:cSld>
-  <p:clrMapOvr>
-    <a:masterClrMapping/>
-  </p:clrMapOvr>
-</p:sld>
-</file>
-
-<file path=ppt/slides/slide20.xml><?xml version="1.0" encoding="utf-8"?>
+<file path=ppt/slides/slide21.xml><?xml version="1.0" encoding="utf-8"?>
 <p:sld xmlns:a="http://schemas.openxmlformats.org/drawingml/2006/main" xmlns:r="http://schemas.openxmlformats.org/officeDocument/2006/relationships" xmlns:p="http://schemas.openxmlformats.org/presentationml/2006/main">
   <p:cSld>
     <p:spTree>
@@ -31328,7 +31940,7 @@
 </p:sld>
 </file>
 
-<file path=ppt/slides/slide21.xml><?xml version="1.0" encoding="utf-8"?>
+<file path=ppt/slides/slide22.xml><?xml version="1.0" encoding="utf-8"?>
 <p:sld xmlns:a="http://schemas.openxmlformats.org/drawingml/2006/main" xmlns:r="http://schemas.openxmlformats.org/officeDocument/2006/relationships" xmlns:p="http://schemas.openxmlformats.org/presentationml/2006/main">
   <p:cSld>
     <p:spTree>
@@ -33093,7 +33705,7 @@
 </p:sld>
 </file>
 
-<file path=ppt/slides/slide22.xml><?xml version="1.0" encoding="utf-8"?>
+<file path=ppt/slides/slide23.xml><?xml version="1.0" encoding="utf-8"?>
 <p:sld xmlns:a="http://schemas.openxmlformats.org/drawingml/2006/main" xmlns:r="http://schemas.openxmlformats.org/officeDocument/2006/relationships" xmlns:p="http://schemas.openxmlformats.org/presentationml/2006/main">
   <p:cSld>
     <p:spTree>
@@ -33607,7 +34219,7 @@
 </p:sld>
 </file>
 
-<file path=ppt/slides/slide23.xml><?xml version="1.0" encoding="utf-8"?>
+<file path=ppt/slides/slide24.xml><?xml version="1.0" encoding="utf-8"?>
 <p:sld xmlns:a="http://schemas.openxmlformats.org/drawingml/2006/main" xmlns:r="http://schemas.openxmlformats.org/officeDocument/2006/relationships" xmlns:p="http://schemas.openxmlformats.org/presentationml/2006/main">
   <p:cSld>
     <p:spTree>
@@ -34296,7 +34908,7 @@
 </p:sld>
 </file>
 
-<file path=ppt/slides/slide24.xml><?xml version="1.0" encoding="utf-8"?>
+<file path=ppt/slides/slide25.xml><?xml version="1.0" encoding="utf-8"?>
 <p:sld xmlns:a="http://schemas.openxmlformats.org/drawingml/2006/main" xmlns:r="http://schemas.openxmlformats.org/officeDocument/2006/relationships" xmlns:p="http://schemas.openxmlformats.org/presentationml/2006/main">
   <p:cSld>
     <p:spTree>
@@ -35034,7 +35646,7 @@
 </p:sld>
 </file>
 
-<file path=ppt/slides/slide25.xml><?xml version="1.0" encoding="utf-8"?>
+<file path=ppt/slides/slide26.xml><?xml version="1.0" encoding="utf-8"?>
 <p:sld xmlns:a="http://schemas.openxmlformats.org/drawingml/2006/main" xmlns:r="http://schemas.openxmlformats.org/officeDocument/2006/relationships" xmlns:p="http://schemas.openxmlformats.org/presentationml/2006/main">
   <p:cSld>
     <p:spTree>
@@ -36020,6 +36632,152 @@
         </p:spPr>
         <p:txBody>
           <a:bodyPr>
+            <a:normAutofit/>
+          </a:bodyPr>
+          <a:lstStyle/>
+          <a:p>
+            <a:r>
+              <a:rPr lang="en-US" dirty="0">
+                <a:solidFill>
+                  <a:schemeClr val="bg1"/>
+                </a:solidFill>
+              </a:rPr>
+              <a:t>Our goal is to estimate the proportion of people with aphantasia. How can we do this?</a:t>
+            </a:r>
+          </a:p>
+          <a:p>
+            <a:pPr marL="0" indent="0">
+              <a:buNone/>
+            </a:pPr>
+            <a:endParaRPr lang="en-US" dirty="0">
+              <a:solidFill>
+                <a:schemeClr val="bg1"/>
+              </a:solidFill>
+            </a:endParaRPr>
+          </a:p>
+          <a:p>
+            <a:pPr marL="514350" indent="-514350">
+              <a:buFont typeface="+mj-lt"/>
+              <a:buAutoNum type="arabicPeriod"/>
+            </a:pPr>
+            <a:r>
+              <a:rPr lang="en-US" dirty="0">
+                <a:solidFill>
+                  <a:schemeClr val="bg1"/>
+                </a:solidFill>
+              </a:rPr>
+              <a:t> </a:t>
+            </a:r>
+          </a:p>
+          <a:p>
+            <a:pPr marL="514350" indent="-514350">
+              <a:buFont typeface="+mj-lt"/>
+              <a:buAutoNum type="arabicPeriod"/>
+            </a:pPr>
+            <a:r>
+              <a:rPr lang="en-NZ" dirty="0">
+                <a:solidFill>
+                  <a:schemeClr val="bg1"/>
+                </a:solidFill>
+              </a:rPr>
+              <a:t> </a:t>
+            </a:r>
+          </a:p>
+        </p:txBody>
+      </p:sp>
+    </p:spTree>
+    <p:extLst>
+      <p:ext uri="{BB962C8B-B14F-4D97-AF65-F5344CB8AC3E}">
+        <p14:creationId xmlns:p14="http://schemas.microsoft.com/office/powerpoint/2010/main" val="111027261"/>
+      </p:ext>
+    </p:extLst>
+  </p:cSld>
+  <p:clrMapOvr>
+    <a:masterClrMapping/>
+  </p:clrMapOvr>
+</p:sld>
+</file>
+
+<file path=ppt/slides/slide7.xml><?xml version="1.0" encoding="utf-8"?>
+<p:sld xmlns:a="http://schemas.openxmlformats.org/drawingml/2006/main" xmlns:r="http://schemas.openxmlformats.org/officeDocument/2006/relationships" xmlns:p="http://schemas.openxmlformats.org/presentationml/2006/main">
+  <p:cSld>
+    <p:spTree>
+      <p:nvGrpSpPr>
+        <p:cNvPr id="1" name="">
+          <a:extLst>
+            <a:ext uri="{FF2B5EF4-FFF2-40B4-BE49-F238E27FC236}">
+              <a16:creationId xmlns:a16="http://schemas.microsoft.com/office/drawing/2014/main" id="{D8E48974-E4C9-E4F4-CA24-176CAA75508B}"/>
+            </a:ext>
+          </a:extLst>
+        </p:cNvPr>
+        <p:cNvGrpSpPr/>
+        <p:nvPr/>
+      </p:nvGrpSpPr>
+      <p:grpSpPr>
+        <a:xfrm>
+          <a:off x="0" y="0"/>
+          <a:ext cx="0" cy="0"/>
+          <a:chOff x="0" y="0"/>
+          <a:chExt cx="0" cy="0"/>
+        </a:xfrm>
+      </p:grpSpPr>
+      <p:sp>
+        <p:nvSpPr>
+          <p:cNvPr id="2" name="Title 1">
+            <a:extLst>
+              <a:ext uri="{FF2B5EF4-FFF2-40B4-BE49-F238E27FC236}">
+                <a16:creationId xmlns:a16="http://schemas.microsoft.com/office/drawing/2014/main" id="{01D02AF0-7275-F43E-C8A8-9FBC2D732DAA}"/>
+              </a:ext>
+            </a:extLst>
+          </p:cNvPr>
+          <p:cNvSpPr>
+            <a:spLocks noGrp="1"/>
+          </p:cNvSpPr>
+          <p:nvPr>
+            <p:ph type="title"/>
+          </p:nvPr>
+        </p:nvSpPr>
+        <p:spPr/>
+        <p:txBody>
+          <a:bodyPr/>
+          <a:lstStyle/>
+          <a:p>
+            <a:r>
+              <a:rPr lang="en-NZ" dirty="0">
+                <a:solidFill>
+                  <a:schemeClr val="bg1"/>
+                </a:solidFill>
+              </a:rPr>
+              <a:t>Aphantasia</a:t>
+            </a:r>
+            <a:endParaRPr lang="en-NZ" dirty="0"/>
+          </a:p>
+        </p:txBody>
+      </p:sp>
+      <p:sp>
+        <p:nvSpPr>
+          <p:cNvPr id="3" name="Content Placeholder 2">
+            <a:extLst>
+              <a:ext uri="{FF2B5EF4-FFF2-40B4-BE49-F238E27FC236}">
+                <a16:creationId xmlns:a16="http://schemas.microsoft.com/office/drawing/2014/main" id="{F312D094-3220-CA65-739C-D5DA17E05B7C}"/>
+              </a:ext>
+            </a:extLst>
+          </p:cNvPr>
+          <p:cNvSpPr>
+            <a:spLocks noGrp="1"/>
+          </p:cNvSpPr>
+          <p:nvPr>
+            <p:ph idx="1"/>
+          </p:nvPr>
+        </p:nvSpPr>
+        <p:spPr>
+          <a:xfrm>
+            <a:off x="838200" y="1825625"/>
+            <a:ext cx="10515600" cy="4392295"/>
+          </a:xfrm>
+        </p:spPr>
+        <p:txBody>
+          <a:bodyPr>
             <a:normAutofit fontScale="92500" lnSpcReduction="20000"/>
           </a:bodyPr>
           <a:lstStyle/>
@@ -36149,7 +36907,7 @@
     </p:spTree>
     <p:extLst>
       <p:ext uri="{BB962C8B-B14F-4D97-AF65-F5344CB8AC3E}">
-        <p14:creationId xmlns:p14="http://schemas.microsoft.com/office/powerpoint/2010/main" val="111027261"/>
+        <p14:creationId xmlns:p14="http://schemas.microsoft.com/office/powerpoint/2010/main" val="2633393311"/>
       </p:ext>
     </p:extLst>
   </p:cSld>
@@ -36159,7 +36917,7 @@
 </p:sld>
 </file>
 
-<file path=ppt/slides/slide7.xml><?xml version="1.0" encoding="utf-8"?>
+<file path=ppt/slides/slide8.xml><?xml version="1.0" encoding="utf-8"?>
 <p:sld xmlns:a="http://schemas.openxmlformats.org/drawingml/2006/main" xmlns:r="http://schemas.openxmlformats.org/officeDocument/2006/relationships" xmlns:p="http://schemas.openxmlformats.org/presentationml/2006/main">
   <p:cSld>
     <p:spTree>
@@ -38910,7 +39668,7 @@
 </p:sld>
 </file>
 
-<file path=ppt/slides/slide8.xml><?xml version="1.0" encoding="utf-8"?>
+<file path=ppt/slides/slide9.xml><?xml version="1.0" encoding="utf-8"?>
 <p:sld xmlns:a="http://schemas.openxmlformats.org/drawingml/2006/main" xmlns:r="http://schemas.openxmlformats.org/officeDocument/2006/relationships" xmlns:p="http://schemas.openxmlformats.org/presentationml/2006/main">
   <p:cSld>
     <p:bg>
@@ -40578,617 +41336,6 @@
   <p:clrMapOvr>
     <a:masterClrMapping/>
   </p:clrMapOvr>
-</p:sld>
-</file>
-
-<file path=ppt/slides/slide9.xml><?xml version="1.0" encoding="utf-8"?>
-<p:sld xmlns:a="http://schemas.openxmlformats.org/drawingml/2006/main" xmlns:r="http://schemas.openxmlformats.org/officeDocument/2006/relationships" xmlns:p="http://schemas.openxmlformats.org/presentationml/2006/main">
-  <p:cSld>
-    <p:spTree>
-      <p:nvGrpSpPr>
-        <p:cNvPr id="1" name="">
-          <a:extLst>
-            <a:ext uri="{FF2B5EF4-FFF2-40B4-BE49-F238E27FC236}">
-              <a16:creationId xmlns:a16="http://schemas.microsoft.com/office/drawing/2014/main" id="{69360240-EC56-4A99-D4EC-0E420A67FCBD}"/>
-            </a:ext>
-          </a:extLst>
-        </p:cNvPr>
-        <p:cNvGrpSpPr/>
-        <p:nvPr/>
-      </p:nvGrpSpPr>
-      <p:grpSpPr>
-        <a:xfrm>
-          <a:off x="0" y="0"/>
-          <a:ext cx="0" cy="0"/>
-          <a:chOff x="0" y="0"/>
-          <a:chExt cx="0" cy="0"/>
-        </a:xfrm>
-      </p:grpSpPr>
-      <p:sp>
-        <p:nvSpPr>
-          <p:cNvPr id="2" name="Title 1">
-            <a:extLst>
-              <a:ext uri="{FF2B5EF4-FFF2-40B4-BE49-F238E27FC236}">
-                <a16:creationId xmlns:a16="http://schemas.microsoft.com/office/drawing/2014/main" id="{13F93581-CA01-F1BC-A0C5-A9568C12E1BA}"/>
-              </a:ext>
-            </a:extLst>
-          </p:cNvPr>
-          <p:cNvSpPr>
-            <a:spLocks noGrp="1"/>
-          </p:cNvSpPr>
-          <p:nvPr>
-            <p:ph type="title"/>
-          </p:nvPr>
-        </p:nvSpPr>
-        <p:spPr>
-          <a:xfrm>
-            <a:off x="838200" y="1094804"/>
-            <a:ext cx="10515600" cy="595884"/>
-          </a:xfrm>
-        </p:spPr>
-        <p:txBody>
-          <a:bodyPr>
-            <a:normAutofit fontScale="90000"/>
-          </a:bodyPr>
-          <a:lstStyle/>
-          <a:p>
-            <a:r>
-              <a:rPr lang="en-NZ" dirty="0">
-                <a:solidFill>
-                  <a:schemeClr val="bg1"/>
-                </a:solidFill>
-              </a:rPr>
-              <a:t>The long inefficient way: counting</a:t>
-            </a:r>
-          </a:p>
-        </p:txBody>
-      </p:sp>
-      <p:grpSp>
-        <p:nvGrpSpPr>
-          <p:cNvPr id="4" name="Group 3">
-            <a:extLst>
-              <a:ext uri="{FF2B5EF4-FFF2-40B4-BE49-F238E27FC236}">
-                <a16:creationId xmlns:a16="http://schemas.microsoft.com/office/drawing/2014/main" id="{194492E4-229A-7EC6-A2FA-947D11122DB9}"/>
-              </a:ext>
-            </a:extLst>
-          </p:cNvPr>
-          <p:cNvGrpSpPr/>
-          <p:nvPr/>
-        </p:nvGrpSpPr>
-        <p:grpSpPr>
-          <a:xfrm rot="5400000" flipH="1">
-            <a:off x="1040508" y="3031997"/>
-            <a:ext cx="595884" cy="618174"/>
-            <a:chOff x="475488" y="1595628"/>
-            <a:chExt cx="3666744" cy="3803904"/>
-          </a:xfrm>
-        </p:grpSpPr>
-        <p:sp>
-          <p:nvSpPr>
-            <p:cNvPr id="5" name="Oval 4">
-              <a:extLst>
-                <a:ext uri="{FF2B5EF4-FFF2-40B4-BE49-F238E27FC236}">
-                  <a16:creationId xmlns:a16="http://schemas.microsoft.com/office/drawing/2014/main" id="{688B6365-ED0F-5D98-D55F-DD89B6AD959E}"/>
-                </a:ext>
-              </a:extLst>
-            </p:cNvPr>
-            <p:cNvSpPr/>
-            <p:nvPr/>
-          </p:nvSpPr>
-          <p:spPr>
-            <a:xfrm>
-              <a:off x="475488" y="1595628"/>
-              <a:ext cx="3666744" cy="3666744"/>
-            </a:xfrm>
-            <a:prstGeom prst="ellipse">
-              <a:avLst/>
-            </a:prstGeom>
-            <a:solidFill>
-              <a:schemeClr val="tx1">
-                <a:lumMod val="85000"/>
-                <a:lumOff val="15000"/>
-              </a:schemeClr>
-            </a:solidFill>
-            <a:ln>
-              <a:noFill/>
-            </a:ln>
-          </p:spPr>
-          <p:style>
-            <a:lnRef idx="2">
-              <a:schemeClr val="accent1">
-                <a:shade val="15000"/>
-              </a:schemeClr>
-            </a:lnRef>
-            <a:fillRef idx="1">
-              <a:schemeClr val="accent1"/>
-            </a:fillRef>
-            <a:effectRef idx="0">
-              <a:schemeClr val="accent1"/>
-            </a:effectRef>
-            <a:fontRef idx="minor">
-              <a:schemeClr val="lt1"/>
-            </a:fontRef>
-          </p:style>
-          <p:txBody>
-            <a:bodyPr rtlCol="0" anchor="ctr"/>
-            <a:lstStyle/>
-            <a:p>
-              <a:pPr algn="ctr"/>
-              <a:endParaRPr lang="en-NZ"/>
-            </a:p>
-          </p:txBody>
-        </p:sp>
-        <p:sp>
-          <p:nvSpPr>
-            <p:cNvPr id="6" name="Partial Circle 5">
-              <a:extLst>
-                <a:ext uri="{FF2B5EF4-FFF2-40B4-BE49-F238E27FC236}">
-                  <a16:creationId xmlns:a16="http://schemas.microsoft.com/office/drawing/2014/main" id="{B936B2F3-761E-2FAC-6FF3-542F40CADEAE}"/>
-                </a:ext>
-              </a:extLst>
-            </p:cNvPr>
-            <p:cNvSpPr/>
-            <p:nvPr/>
-          </p:nvSpPr>
-          <p:spPr>
-            <a:xfrm rot="16200000">
-              <a:off x="406908" y="1664208"/>
-              <a:ext cx="3803904" cy="3666744"/>
-            </a:xfrm>
-            <a:prstGeom prst="pie">
-              <a:avLst>
-                <a:gd name="adj1" fmla="val 28755"/>
-                <a:gd name="adj2" fmla="val 5418458"/>
-              </a:avLst>
-            </a:prstGeom>
-            <a:solidFill>
-              <a:schemeClr val="accent2">
-                <a:lumMod val="60000"/>
-                <a:lumOff val="40000"/>
-              </a:schemeClr>
-            </a:solidFill>
-            <a:ln>
-              <a:noFill/>
-            </a:ln>
-          </p:spPr>
-          <p:style>
-            <a:lnRef idx="2">
-              <a:schemeClr val="accent1">
-                <a:shade val="15000"/>
-              </a:schemeClr>
-            </a:lnRef>
-            <a:fillRef idx="1">
-              <a:schemeClr val="accent1"/>
-            </a:fillRef>
-            <a:effectRef idx="0">
-              <a:schemeClr val="accent1"/>
-            </a:effectRef>
-            <a:fontRef idx="minor">
-              <a:schemeClr val="lt1"/>
-            </a:fontRef>
-          </p:style>
-          <p:txBody>
-            <a:bodyPr rtlCol="0" anchor="ctr"/>
-            <a:lstStyle/>
-            <a:p>
-              <a:pPr algn="ctr"/>
-              <a:endParaRPr lang="en-NZ">
-                <a:solidFill>
-                  <a:schemeClr val="tx1"/>
-                </a:solidFill>
-              </a:endParaRPr>
-            </a:p>
-          </p:txBody>
-        </p:sp>
-      </p:grpSp>
-      <p:grpSp>
-        <p:nvGrpSpPr>
-          <p:cNvPr id="7" name="Group 6">
-            <a:extLst>
-              <a:ext uri="{FF2B5EF4-FFF2-40B4-BE49-F238E27FC236}">
-                <a16:creationId xmlns:a16="http://schemas.microsoft.com/office/drawing/2014/main" id="{58F18D39-0B51-4F30-D3FC-E7184993C181}"/>
-              </a:ext>
-            </a:extLst>
-          </p:cNvPr>
-          <p:cNvGrpSpPr/>
-          <p:nvPr/>
-        </p:nvGrpSpPr>
-        <p:grpSpPr>
-          <a:xfrm rot="10800000" flipH="1">
-            <a:off x="1062797" y="3837813"/>
-            <a:ext cx="595884" cy="595884"/>
-            <a:chOff x="4916424" y="1690688"/>
-            <a:chExt cx="3666744" cy="3666744"/>
-          </a:xfrm>
-        </p:grpSpPr>
-        <p:sp>
-          <p:nvSpPr>
-            <p:cNvPr id="8" name="Oval 7">
-              <a:extLst>
-                <a:ext uri="{FF2B5EF4-FFF2-40B4-BE49-F238E27FC236}">
-                  <a16:creationId xmlns:a16="http://schemas.microsoft.com/office/drawing/2014/main" id="{CE4DDD9D-3551-23CC-8168-E41EC9CE6603}"/>
-                </a:ext>
-              </a:extLst>
-            </p:cNvPr>
-            <p:cNvSpPr/>
-            <p:nvPr/>
-          </p:nvSpPr>
-          <p:spPr>
-            <a:xfrm>
-              <a:off x="4916424" y="1690688"/>
-              <a:ext cx="3666744" cy="3666744"/>
-            </a:xfrm>
-            <a:prstGeom prst="ellipse">
-              <a:avLst/>
-            </a:prstGeom>
-            <a:solidFill>
-              <a:schemeClr val="tx1">
-                <a:lumMod val="85000"/>
-                <a:lumOff val="15000"/>
-              </a:schemeClr>
-            </a:solidFill>
-            <a:ln>
-              <a:noFill/>
-            </a:ln>
-          </p:spPr>
-          <p:style>
-            <a:lnRef idx="2">
-              <a:schemeClr val="accent1">
-                <a:shade val="15000"/>
-              </a:schemeClr>
-            </a:lnRef>
-            <a:fillRef idx="1">
-              <a:schemeClr val="accent1"/>
-            </a:fillRef>
-            <a:effectRef idx="0">
-              <a:schemeClr val="accent1"/>
-            </a:effectRef>
-            <a:fontRef idx="minor">
-              <a:schemeClr val="lt1"/>
-            </a:fontRef>
-          </p:style>
-          <p:txBody>
-            <a:bodyPr rtlCol="0" anchor="ctr"/>
-            <a:lstStyle/>
-            <a:p>
-              <a:pPr algn="ctr"/>
-              <a:endParaRPr lang="en-NZ"/>
-            </a:p>
-          </p:txBody>
-        </p:sp>
-        <p:sp>
-          <p:nvSpPr>
-            <p:cNvPr id="9" name="Partial Circle 8">
-              <a:extLst>
-                <a:ext uri="{FF2B5EF4-FFF2-40B4-BE49-F238E27FC236}">
-                  <a16:creationId xmlns:a16="http://schemas.microsoft.com/office/drawing/2014/main" id="{C6B1DD03-53D0-FAF4-BBA4-3827A1A35D8C}"/>
-                </a:ext>
-              </a:extLst>
-            </p:cNvPr>
-            <p:cNvSpPr/>
-            <p:nvPr/>
-          </p:nvSpPr>
-          <p:spPr>
-            <a:xfrm rot="16200000">
-              <a:off x="4916424" y="1690688"/>
-              <a:ext cx="3666744" cy="3666744"/>
-            </a:xfrm>
-            <a:prstGeom prst="pie">
-              <a:avLst>
-                <a:gd name="adj1" fmla="val 28755"/>
-                <a:gd name="adj2" fmla="val 10825612"/>
-              </a:avLst>
-            </a:prstGeom>
-            <a:solidFill>
-              <a:schemeClr val="accent2">
-                <a:lumMod val="60000"/>
-                <a:lumOff val="40000"/>
-              </a:schemeClr>
-            </a:solidFill>
-            <a:ln>
-              <a:noFill/>
-            </a:ln>
-          </p:spPr>
-          <p:style>
-            <a:lnRef idx="2">
-              <a:schemeClr val="accent1">
-                <a:shade val="15000"/>
-              </a:schemeClr>
-            </a:lnRef>
-            <a:fillRef idx="1">
-              <a:schemeClr val="accent1"/>
-            </a:fillRef>
-            <a:effectRef idx="0">
-              <a:schemeClr val="accent1"/>
-            </a:effectRef>
-            <a:fontRef idx="minor">
-              <a:schemeClr val="lt1"/>
-            </a:fontRef>
-          </p:style>
-          <p:txBody>
-            <a:bodyPr rtlCol="0" anchor="ctr"/>
-            <a:lstStyle/>
-            <a:p>
-              <a:pPr algn="ctr"/>
-              <a:endParaRPr lang="en-NZ">
-                <a:solidFill>
-                  <a:schemeClr val="tx1"/>
-                </a:solidFill>
-              </a:endParaRPr>
-            </a:p>
-          </p:txBody>
-        </p:sp>
-      </p:grpSp>
-      <p:grpSp>
-        <p:nvGrpSpPr>
-          <p:cNvPr id="10" name="Group 9">
-            <a:extLst>
-              <a:ext uri="{FF2B5EF4-FFF2-40B4-BE49-F238E27FC236}">
-                <a16:creationId xmlns:a16="http://schemas.microsoft.com/office/drawing/2014/main" id="{7ABC2C2B-B40F-BF0A-E720-A4340FCD540B}"/>
-              </a:ext>
-            </a:extLst>
-          </p:cNvPr>
-          <p:cNvGrpSpPr/>
-          <p:nvPr/>
-        </p:nvGrpSpPr>
-        <p:grpSpPr>
-          <a:xfrm rot="16200000" flipH="1">
-            <a:off x="1029362" y="4632484"/>
-            <a:ext cx="595884" cy="595884"/>
-            <a:chOff x="8145780" y="1528572"/>
-            <a:chExt cx="3666744" cy="3666744"/>
-          </a:xfrm>
-        </p:grpSpPr>
-        <p:sp>
-          <p:nvSpPr>
-            <p:cNvPr id="11" name="Oval 10">
-              <a:extLst>
-                <a:ext uri="{FF2B5EF4-FFF2-40B4-BE49-F238E27FC236}">
-                  <a16:creationId xmlns:a16="http://schemas.microsoft.com/office/drawing/2014/main" id="{C99B8009-D50C-F86A-1449-F367D1831411}"/>
-                </a:ext>
-              </a:extLst>
-            </p:cNvPr>
-            <p:cNvSpPr/>
-            <p:nvPr/>
-          </p:nvSpPr>
-          <p:spPr>
-            <a:xfrm>
-              <a:off x="8145780" y="1528572"/>
-              <a:ext cx="3666744" cy="3666744"/>
-            </a:xfrm>
-            <a:prstGeom prst="ellipse">
-              <a:avLst/>
-            </a:prstGeom>
-            <a:solidFill>
-              <a:schemeClr val="tx1">
-                <a:lumMod val="85000"/>
-                <a:lumOff val="15000"/>
-              </a:schemeClr>
-            </a:solidFill>
-            <a:ln>
-              <a:noFill/>
-            </a:ln>
-          </p:spPr>
-          <p:style>
-            <a:lnRef idx="2">
-              <a:schemeClr val="accent1">
-                <a:shade val="15000"/>
-              </a:schemeClr>
-            </a:lnRef>
-            <a:fillRef idx="1">
-              <a:schemeClr val="accent1"/>
-            </a:fillRef>
-            <a:effectRef idx="0">
-              <a:schemeClr val="accent1"/>
-            </a:effectRef>
-            <a:fontRef idx="minor">
-              <a:schemeClr val="lt1"/>
-            </a:fontRef>
-          </p:style>
-          <p:txBody>
-            <a:bodyPr rtlCol="0" anchor="ctr"/>
-            <a:lstStyle/>
-            <a:p>
-              <a:pPr algn="ctr"/>
-              <a:endParaRPr lang="en-NZ"/>
-            </a:p>
-          </p:txBody>
-        </p:sp>
-        <p:sp>
-          <p:nvSpPr>
-            <p:cNvPr id="12" name="Partial Circle 11">
-              <a:extLst>
-                <a:ext uri="{FF2B5EF4-FFF2-40B4-BE49-F238E27FC236}">
-                  <a16:creationId xmlns:a16="http://schemas.microsoft.com/office/drawing/2014/main" id="{11EBD056-EC85-05CE-4EF5-04CD3215B77C}"/>
-                </a:ext>
-              </a:extLst>
-            </p:cNvPr>
-            <p:cNvSpPr/>
-            <p:nvPr/>
-          </p:nvSpPr>
-          <p:spPr>
-            <a:xfrm rot="16200000">
-              <a:off x="8145780" y="1528572"/>
-              <a:ext cx="3666744" cy="3666744"/>
-            </a:xfrm>
-            <a:prstGeom prst="pie">
-              <a:avLst>
-                <a:gd name="adj1" fmla="val 28755"/>
-                <a:gd name="adj2" fmla="val 16212288"/>
-              </a:avLst>
-            </a:prstGeom>
-            <a:solidFill>
-              <a:schemeClr val="accent2">
-                <a:lumMod val="60000"/>
-                <a:lumOff val="40000"/>
-              </a:schemeClr>
-            </a:solidFill>
-            <a:ln>
-              <a:noFill/>
-            </a:ln>
-          </p:spPr>
-          <p:style>
-            <a:lnRef idx="2">
-              <a:schemeClr val="accent1">
-                <a:shade val="15000"/>
-              </a:schemeClr>
-            </a:lnRef>
-            <a:fillRef idx="1">
-              <a:schemeClr val="accent1"/>
-            </a:fillRef>
-            <a:effectRef idx="0">
-              <a:schemeClr val="accent1"/>
-            </a:effectRef>
-            <a:fontRef idx="minor">
-              <a:schemeClr val="lt1"/>
-            </a:fontRef>
-          </p:style>
-          <p:txBody>
-            <a:bodyPr rtlCol="0" anchor="ctr"/>
-            <a:lstStyle/>
-            <a:p>
-              <a:pPr algn="ctr"/>
-              <a:endParaRPr lang="en-NZ">
-                <a:solidFill>
-                  <a:schemeClr val="tx1"/>
-                </a:solidFill>
-              </a:endParaRPr>
-            </a:p>
-          </p:txBody>
-        </p:sp>
-      </p:grpSp>
-      <p:sp>
-        <p:nvSpPr>
-          <p:cNvPr id="13" name="Oval 12">
-            <a:extLst>
-              <a:ext uri="{FF2B5EF4-FFF2-40B4-BE49-F238E27FC236}">
-                <a16:creationId xmlns:a16="http://schemas.microsoft.com/office/drawing/2014/main" id="{C84B0BAB-927C-5589-F10D-811EC9442761}"/>
-              </a:ext>
-            </a:extLst>
-          </p:cNvPr>
-          <p:cNvSpPr/>
-          <p:nvPr/>
-        </p:nvSpPr>
-        <p:spPr>
-          <a:xfrm flipH="1">
-            <a:off x="1040507" y="5427154"/>
-            <a:ext cx="595884" cy="595884"/>
-          </a:xfrm>
-          <a:prstGeom prst="ellipse">
-            <a:avLst/>
-          </a:prstGeom>
-          <a:solidFill>
-            <a:schemeClr val="accent2">
-              <a:lumMod val="60000"/>
-              <a:lumOff val="40000"/>
-            </a:schemeClr>
-          </a:solidFill>
-          <a:ln>
-            <a:noFill/>
-          </a:ln>
-        </p:spPr>
-        <p:style>
-          <a:lnRef idx="2">
-            <a:schemeClr val="accent1">
-              <a:shade val="15000"/>
-            </a:schemeClr>
-          </a:lnRef>
-          <a:fillRef idx="1">
-            <a:schemeClr val="accent1"/>
-          </a:fillRef>
-          <a:effectRef idx="0">
-            <a:schemeClr val="accent1"/>
-          </a:effectRef>
-          <a:fontRef idx="minor">
-            <a:schemeClr val="lt1"/>
-          </a:fontRef>
-        </p:style>
-        <p:txBody>
-          <a:bodyPr rtlCol="0" anchor="ctr"/>
-          <a:lstStyle/>
-          <a:p>
-            <a:pPr algn="ctr"/>
-            <a:endParaRPr lang="en-NZ"/>
-          </a:p>
-        </p:txBody>
-      </p:sp>
-      <p:sp>
-        <p:nvSpPr>
-          <p:cNvPr id="14" name="Oval 13">
-            <a:extLst>
-              <a:ext uri="{FF2B5EF4-FFF2-40B4-BE49-F238E27FC236}">
-                <a16:creationId xmlns:a16="http://schemas.microsoft.com/office/drawing/2014/main" id="{D2CDF11C-4E3F-1F5C-1CEC-87539EFA8724}"/>
-              </a:ext>
-            </a:extLst>
-          </p:cNvPr>
-          <p:cNvSpPr/>
-          <p:nvPr/>
-        </p:nvSpPr>
-        <p:spPr>
-          <a:xfrm flipH="1">
-            <a:off x="1051653" y="2248472"/>
-            <a:ext cx="595884" cy="595884"/>
-          </a:xfrm>
-          <a:prstGeom prst="ellipse">
-            <a:avLst/>
-          </a:prstGeom>
-          <a:solidFill>
-            <a:schemeClr val="tx1">
-              <a:lumMod val="85000"/>
-              <a:lumOff val="15000"/>
-            </a:schemeClr>
-          </a:solidFill>
-          <a:ln>
-            <a:noFill/>
-          </a:ln>
-        </p:spPr>
-        <p:style>
-          <a:lnRef idx="2">
-            <a:schemeClr val="accent1">
-              <a:shade val="15000"/>
-            </a:schemeClr>
-          </a:lnRef>
-          <a:fillRef idx="1">
-            <a:schemeClr val="accent1"/>
-          </a:fillRef>
-          <a:effectRef idx="0">
-            <a:schemeClr val="accent1"/>
-          </a:effectRef>
-          <a:fontRef idx="minor">
-            <a:schemeClr val="lt1"/>
-          </a:fontRef>
-        </p:style>
-        <p:txBody>
-          <a:bodyPr rtlCol="0" anchor="ctr"/>
-          <a:lstStyle/>
-          <a:p>
-            <a:pPr algn="ctr"/>
-            <a:endParaRPr lang="en-NZ"/>
-          </a:p>
-        </p:txBody>
-      </p:sp>
-    </p:spTree>
-    <p:extLst>
-      <p:ext uri="{BB962C8B-B14F-4D97-AF65-F5344CB8AC3E}">
-        <p14:creationId xmlns:p14="http://schemas.microsoft.com/office/powerpoint/2010/main" val="3302430848"/>
-      </p:ext>
-    </p:extLst>
-  </p:cSld>
-  <p:clrMapOvr>
-    <a:masterClrMapping/>
-  </p:clrMapOvr>
-  <mc:AlternateContent xmlns:mc="http://schemas.openxmlformats.org/markup-compatibility/2006" xmlns:p159="http://schemas.microsoft.com/office/powerpoint/2015/09/main">
-    <mc:Choice Requires="p159">
-      <p:transition xmlns:p14="http://schemas.microsoft.com/office/powerpoint/2010/main" spd="slow" p14:dur="2000">
-        <p159:morph option="byObject"/>
-      </p:transition>
-    </mc:Choice>
-    <mc:Fallback xmlns="">
-      <p:transition spd="slow">
-        <p:fade/>
-      </p:transition>
-    </mc:Fallback>
-  </mc:AlternateContent>
 </p:sld>
 </file>
 

</xml_diff>